<commit_message>
Claude: robust text/JSON fallback; don't cache rules briefing when Claude is configured; deck v2
Co-Authored-By: Claude Opus 5.5 <noreply@anthropic.com>
Claude-Session: https://claude.ai/code/session_013THLfcJW9VDMCrGcY4Zx8d
</commit_message>
<xml_diff>
--- a/pitch/Windfall-deck.pptx
+++ b/pitch/Windfall-deck.pptx
@@ -41979,44 +41979,409 @@
           </a:p>
         </p:txBody>
       </p:sp>
-      <p:sp>
-        <p:nvSpPr>
-          <p:cNvPr id="15" name="TextBox 14"/>
-          <p:cNvSpPr txBox="1"/>
-          <p:nvPr/>
-        </p:nvSpPr>
-        <p:spPr>
-          <a:xfrm>
-            <a:off x="571500" y="5715000"/>
-            <a:ext cx="2628900" cy="133350"/>
-          </a:xfrm>
-          <a:prstGeom prst="rect">
-            <a:avLst/>
-          </a:prstGeom>
-          <a:noFill/>
-        </p:spPr>
-        <p:txBody>
-          <a:bodyPr wrap="square" anchor="t" lIns="0" rIns="0" tIns="0" bIns="0">
-            <a:spAutoFit/>
-          </a:bodyPr>
-          <a:lstStyle/>
-          <a:p>
-            <a:pPr algn="ctr"/>
-            <a:r>
-              <a:rPr sz="800" b="0">
-                <a:solidFill>
-                  <a:srgbClr val="7A7262"/>
-                </a:solidFill>
-                <a:latin typeface="IBM Plex Mono"/>
-              </a:rPr>
-              <a:t>[ PHOTO ]</a:t>
-            </a:r>
-          </a:p>
-        </p:txBody>
-      </p:sp>
-      <p:sp>
-        <p:nvSpPr>
-          <p:cNvPr id="16" name="TextBox 15"/>
+      <p:pic>
+        <p:nvPicPr>
+          <p:cNvPr id="15" name="Picture 14" descr="photo.jpg"/>
+          <p:cNvPicPr>
+            <a:picLocks noChangeAspect="1"/>
+          </p:cNvPicPr>
+          <p:nvPr/>
+        </p:nvPicPr>
+        <p:blipFill>
+          <a:blip r:embed="rId2"/>
+          <a:stretch>
+            <a:fillRect/>
+          </a:stretch>
+        </p:blipFill>
+        <p:spPr>
+          <a:xfrm>
+            <a:off x="457200" y="2495550"/>
+            <a:ext cx="2857500" cy="3429000"/>
+          </a:xfrm>
+          <a:prstGeom prst="rect">
+            <a:avLst/>
+          </a:prstGeom>
+        </p:spPr>
+      </p:pic>
+      <p:sp>
+        <p:nvSpPr>
+          <p:cNvPr id="16" name="Rectangle 15"/>
+          <p:cNvSpPr/>
+          <p:nvPr/>
+        </p:nvSpPr>
+        <p:spPr>
+          <a:xfrm>
+            <a:off x="457200" y="2495550"/>
+            <a:ext cx="114300" cy="19050"/>
+          </a:xfrm>
+          <a:prstGeom prst="rect">
+            <a:avLst/>
+          </a:prstGeom>
+          <a:solidFill>
+            <a:srgbClr val="2F2B22"/>
+          </a:solidFill>
+          <a:ln>
+            <a:noFill/>
+          </a:ln>
+          <a:effectLst/>
+        </p:spPr>
+        <p:style>
+          <a:lnRef idx="1">
+            <a:schemeClr val="accent1"/>
+          </a:lnRef>
+          <a:fillRef idx="3">
+            <a:schemeClr val="accent1"/>
+          </a:fillRef>
+          <a:effectRef idx="2">
+            <a:schemeClr val="accent1"/>
+          </a:effectRef>
+          <a:fontRef idx="minor">
+            <a:schemeClr val="lt1"/>
+          </a:fontRef>
+        </p:style>
+        <p:txBody>
+          <a:bodyPr rtlCol="0" anchor="ctr"/>
+          <a:lstStyle/>
+          <a:p>
+            <a:pPr algn="ctr"/>
+          </a:p>
+        </p:txBody>
+      </p:sp>
+      <p:sp>
+        <p:nvSpPr>
+          <p:cNvPr id="17" name="Rectangle 16"/>
+          <p:cNvSpPr/>
+          <p:nvPr/>
+        </p:nvSpPr>
+        <p:spPr>
+          <a:xfrm>
+            <a:off x="457200" y="2495550"/>
+            <a:ext cx="19050" cy="114300"/>
+          </a:xfrm>
+          <a:prstGeom prst="rect">
+            <a:avLst/>
+          </a:prstGeom>
+          <a:solidFill>
+            <a:srgbClr val="2F2B22"/>
+          </a:solidFill>
+          <a:ln>
+            <a:noFill/>
+          </a:ln>
+          <a:effectLst/>
+        </p:spPr>
+        <p:style>
+          <a:lnRef idx="1">
+            <a:schemeClr val="accent1"/>
+          </a:lnRef>
+          <a:fillRef idx="3">
+            <a:schemeClr val="accent1"/>
+          </a:fillRef>
+          <a:effectRef idx="2">
+            <a:schemeClr val="accent1"/>
+          </a:effectRef>
+          <a:fontRef idx="minor">
+            <a:schemeClr val="lt1"/>
+          </a:fontRef>
+        </p:style>
+        <p:txBody>
+          <a:bodyPr rtlCol="0" anchor="ctr"/>
+          <a:lstStyle/>
+          <a:p>
+            <a:pPr algn="ctr"/>
+          </a:p>
+        </p:txBody>
+      </p:sp>
+      <p:sp>
+        <p:nvSpPr>
+          <p:cNvPr id="18" name="Rectangle 17"/>
+          <p:cNvSpPr/>
+          <p:nvPr/>
+        </p:nvSpPr>
+        <p:spPr>
+          <a:xfrm>
+            <a:off x="3200400" y="2495550"/>
+            <a:ext cx="114300" cy="19050"/>
+          </a:xfrm>
+          <a:prstGeom prst="rect">
+            <a:avLst/>
+          </a:prstGeom>
+          <a:solidFill>
+            <a:srgbClr val="2F2B22"/>
+          </a:solidFill>
+          <a:ln>
+            <a:noFill/>
+          </a:ln>
+          <a:effectLst/>
+        </p:spPr>
+        <p:style>
+          <a:lnRef idx="1">
+            <a:schemeClr val="accent1"/>
+          </a:lnRef>
+          <a:fillRef idx="3">
+            <a:schemeClr val="accent1"/>
+          </a:fillRef>
+          <a:effectRef idx="2">
+            <a:schemeClr val="accent1"/>
+          </a:effectRef>
+          <a:fontRef idx="minor">
+            <a:schemeClr val="lt1"/>
+          </a:fontRef>
+        </p:style>
+        <p:txBody>
+          <a:bodyPr rtlCol="0" anchor="ctr"/>
+          <a:lstStyle/>
+          <a:p>
+            <a:pPr algn="ctr"/>
+          </a:p>
+        </p:txBody>
+      </p:sp>
+      <p:sp>
+        <p:nvSpPr>
+          <p:cNvPr id="19" name="Rectangle 18"/>
+          <p:cNvSpPr/>
+          <p:nvPr/>
+        </p:nvSpPr>
+        <p:spPr>
+          <a:xfrm>
+            <a:off x="3295650" y="2495550"/>
+            <a:ext cx="19050" cy="114300"/>
+          </a:xfrm>
+          <a:prstGeom prst="rect">
+            <a:avLst/>
+          </a:prstGeom>
+          <a:solidFill>
+            <a:srgbClr val="2F2B22"/>
+          </a:solidFill>
+          <a:ln>
+            <a:noFill/>
+          </a:ln>
+          <a:effectLst/>
+        </p:spPr>
+        <p:style>
+          <a:lnRef idx="1">
+            <a:schemeClr val="accent1"/>
+          </a:lnRef>
+          <a:fillRef idx="3">
+            <a:schemeClr val="accent1"/>
+          </a:fillRef>
+          <a:effectRef idx="2">
+            <a:schemeClr val="accent1"/>
+          </a:effectRef>
+          <a:fontRef idx="minor">
+            <a:schemeClr val="lt1"/>
+          </a:fontRef>
+        </p:style>
+        <p:txBody>
+          <a:bodyPr rtlCol="0" anchor="ctr"/>
+          <a:lstStyle/>
+          <a:p>
+            <a:pPr algn="ctr"/>
+          </a:p>
+        </p:txBody>
+      </p:sp>
+      <p:sp>
+        <p:nvSpPr>
+          <p:cNvPr id="20" name="Rectangle 19"/>
+          <p:cNvSpPr/>
+          <p:nvPr/>
+        </p:nvSpPr>
+        <p:spPr>
+          <a:xfrm>
+            <a:off x="457200" y="5905500"/>
+            <a:ext cx="114300" cy="19050"/>
+          </a:xfrm>
+          <a:prstGeom prst="rect">
+            <a:avLst/>
+          </a:prstGeom>
+          <a:solidFill>
+            <a:srgbClr val="2F2B22"/>
+          </a:solidFill>
+          <a:ln>
+            <a:noFill/>
+          </a:ln>
+          <a:effectLst/>
+        </p:spPr>
+        <p:style>
+          <a:lnRef idx="1">
+            <a:schemeClr val="accent1"/>
+          </a:lnRef>
+          <a:fillRef idx="3">
+            <a:schemeClr val="accent1"/>
+          </a:fillRef>
+          <a:effectRef idx="2">
+            <a:schemeClr val="accent1"/>
+          </a:effectRef>
+          <a:fontRef idx="minor">
+            <a:schemeClr val="lt1"/>
+          </a:fontRef>
+        </p:style>
+        <p:txBody>
+          <a:bodyPr rtlCol="0" anchor="ctr"/>
+          <a:lstStyle/>
+          <a:p>
+            <a:pPr algn="ctr"/>
+          </a:p>
+        </p:txBody>
+      </p:sp>
+      <p:sp>
+        <p:nvSpPr>
+          <p:cNvPr id="21" name="Rectangle 20"/>
+          <p:cNvSpPr/>
+          <p:nvPr/>
+        </p:nvSpPr>
+        <p:spPr>
+          <a:xfrm>
+            <a:off x="457200" y="5810250"/>
+            <a:ext cx="19050" cy="114300"/>
+          </a:xfrm>
+          <a:prstGeom prst="rect">
+            <a:avLst/>
+          </a:prstGeom>
+          <a:solidFill>
+            <a:srgbClr val="2F2B22"/>
+          </a:solidFill>
+          <a:ln>
+            <a:noFill/>
+          </a:ln>
+          <a:effectLst/>
+        </p:spPr>
+        <p:style>
+          <a:lnRef idx="1">
+            <a:schemeClr val="accent1"/>
+          </a:lnRef>
+          <a:fillRef idx="3">
+            <a:schemeClr val="accent1"/>
+          </a:fillRef>
+          <a:effectRef idx="2">
+            <a:schemeClr val="accent1"/>
+          </a:effectRef>
+          <a:fontRef idx="minor">
+            <a:schemeClr val="lt1"/>
+          </a:fontRef>
+        </p:style>
+        <p:txBody>
+          <a:bodyPr rtlCol="0" anchor="ctr"/>
+          <a:lstStyle/>
+          <a:p>
+            <a:pPr algn="ctr"/>
+          </a:p>
+        </p:txBody>
+      </p:sp>
+      <p:sp>
+        <p:nvSpPr>
+          <p:cNvPr id="22" name="Rectangle 21"/>
+          <p:cNvSpPr/>
+          <p:nvPr/>
+        </p:nvSpPr>
+        <p:spPr>
+          <a:xfrm>
+            <a:off x="3200400" y="5905500"/>
+            <a:ext cx="114300" cy="19050"/>
+          </a:xfrm>
+          <a:prstGeom prst="rect">
+            <a:avLst/>
+          </a:prstGeom>
+          <a:solidFill>
+            <a:srgbClr val="2F2B22"/>
+          </a:solidFill>
+          <a:ln>
+            <a:noFill/>
+          </a:ln>
+          <a:effectLst/>
+        </p:spPr>
+        <p:style>
+          <a:lnRef idx="1">
+            <a:schemeClr val="accent1"/>
+          </a:lnRef>
+          <a:fillRef idx="3">
+            <a:schemeClr val="accent1"/>
+          </a:fillRef>
+          <a:effectRef idx="2">
+            <a:schemeClr val="accent1"/>
+          </a:effectRef>
+          <a:fontRef idx="minor">
+            <a:schemeClr val="lt1"/>
+          </a:fontRef>
+        </p:style>
+        <p:txBody>
+          <a:bodyPr rtlCol="0" anchor="ctr"/>
+          <a:lstStyle/>
+          <a:p>
+            <a:pPr algn="ctr"/>
+          </a:p>
+        </p:txBody>
+      </p:sp>
+      <p:sp>
+        <p:nvSpPr>
+          <p:cNvPr id="23" name="Rectangle 22"/>
+          <p:cNvSpPr/>
+          <p:nvPr/>
+        </p:nvSpPr>
+        <p:spPr>
+          <a:xfrm>
+            <a:off x="3295650" y="5810250"/>
+            <a:ext cx="19050" cy="114300"/>
+          </a:xfrm>
+          <a:prstGeom prst="rect">
+            <a:avLst/>
+          </a:prstGeom>
+          <a:solidFill>
+            <a:srgbClr val="2F2B22"/>
+          </a:solidFill>
+          <a:ln>
+            <a:noFill/>
+          </a:ln>
+          <a:effectLst/>
+        </p:spPr>
+        <p:style>
+          <a:lnRef idx="1">
+            <a:schemeClr val="accent1"/>
+          </a:lnRef>
+          <a:fillRef idx="3">
+            <a:schemeClr val="accent1"/>
+          </a:fillRef>
+          <a:effectRef idx="2">
+            <a:schemeClr val="accent1"/>
+          </a:effectRef>
+          <a:fontRef idx="minor">
+            <a:schemeClr val="lt1"/>
+          </a:fontRef>
+        </p:style>
+        <p:txBody>
+          <a:bodyPr rtlCol="0" anchor="ctr"/>
+          <a:lstStyle/>
+          <a:p>
+            <a:pPr algn="ctr"/>
+          </a:p>
+        </p:txBody>
+      </p:sp>
+      <p:pic>
+        <p:nvPicPr>
+          <p:cNvPr id="24" name="Picture 23" descr="dvb-logo.png"/>
+          <p:cNvPicPr>
+            <a:picLocks noChangeAspect="1"/>
+          </p:cNvPicPr>
+          <p:nvPr/>
+        </p:nvPicPr>
+        <p:blipFill>
+          <a:blip r:embed="rId3"/>
+          <a:stretch>
+            <a:fillRect/>
+          </a:stretch>
+        </p:blipFill>
+        <p:spPr>
+          <a:xfrm>
+            <a:off x="9906000" y="2495550"/>
+            <a:ext cx="1809750" cy="895350"/>
+          </a:xfrm>
+          <a:prstGeom prst="rect">
+            <a:avLst/>
+          </a:prstGeom>
+        </p:spPr>
+      </p:pic>
+      <p:sp>
+        <p:nvSpPr>
+          <p:cNvPr id="25" name="TextBox 24"/>
           <p:cNvSpPr txBox="1"/>
           <p:nvPr/>
         </p:nvSpPr>
@@ -42051,7 +42416,7 @@
       </p:sp>
       <p:sp>
         <p:nvSpPr>
-          <p:cNvPr id="17" name="TextBox 16"/>
+          <p:cNvPr id="26" name="TextBox 25"/>
           <p:cNvSpPr txBox="1"/>
           <p:nvPr/>
         </p:nvSpPr>
@@ -42086,7 +42451,7 @@
       </p:sp>
       <p:sp>
         <p:nvSpPr>
-          <p:cNvPr id="18" name="TextBox 17"/>
+          <p:cNvPr id="27" name="TextBox 26"/>
           <p:cNvSpPr txBox="1"/>
           <p:nvPr/>
         </p:nvSpPr>
@@ -42121,7 +42486,7 @@
       </p:sp>
       <p:sp>
         <p:nvSpPr>
-          <p:cNvPr id="19" name="TextBox 18"/>
+          <p:cNvPr id="28" name="TextBox 27"/>
           <p:cNvSpPr txBox="1"/>
           <p:nvPr/>
         </p:nvSpPr>
@@ -42153,14 +42518,14 @@
                 </a:solidFill>
                 <a:latin typeface="IBM Plex Mono"/>
               </a:rPr>
-              <a:t>M1 Financial Engineering &amp; Mathematics, ESILV (Paris – La Défense). Previously CPGE PTSI, Lycée Raspail.</a:t>
+              <a:t>M1 Financial Engineering &amp; Mathematics, ESILV.</a:t>
             </a:r>
           </a:p>
         </p:txBody>
       </p:sp>
       <p:sp>
         <p:nvSpPr>
-          <p:cNvPr id="20" name="TextBox 19"/>
+          <p:cNvPr id="29" name="TextBox 28"/>
           <p:cNvSpPr txBox="1"/>
           <p:nvPr/>
         </p:nvSpPr>
@@ -42195,7 +42560,7 @@
       </p:sp>
       <p:sp>
         <p:nvSpPr>
-          <p:cNvPr id="21" name="TextBox 20"/>
+          <p:cNvPr id="30" name="TextBox 29"/>
           <p:cNvSpPr txBox="1"/>
           <p:nvPr/>
         </p:nvSpPr>
@@ -42227,14 +42592,14 @@
                 </a:solidFill>
                 <a:latin typeface="IBM Plex Mono"/>
               </a:rPr>
-              <a:t>Events Lead at DeVinci Blockchain (DVB), the Web3 association of the Pôle Léonard de Vinci. Organises the association’s events and represents DVB at hackathons.</a:t>
+              <a:t>Events Lead at DeVinci Blockchain (DVB), the Web3 association of De Vinci Higher Education. Organises the association’s events and represents DVB at hackathons.</a:t>
             </a:r>
           </a:p>
         </p:txBody>
       </p:sp>
       <p:sp>
         <p:nvSpPr>
-          <p:cNvPr id="22" name="TextBox 21"/>
+          <p:cNvPr id="31" name="TextBox 30"/>
           <p:cNvSpPr txBox="1"/>
           <p:nvPr/>
         </p:nvSpPr>
@@ -42269,7 +42634,7 @@
       </p:sp>
       <p:sp>
         <p:nvSpPr>
-          <p:cNvPr id="23" name="TextBox 22"/>
+          <p:cNvPr id="32" name="TextBox 31"/>
           <p:cNvSpPr txBox="1"/>
           <p:nvPr/>
         </p:nvSpPr>
@@ -42308,7 +42673,7 @@
       </p:sp>
       <p:sp>
         <p:nvSpPr>
-          <p:cNvPr id="24" name="TextBox 23"/>
+          <p:cNvPr id="33" name="TextBox 32"/>
           <p:cNvSpPr txBox="1"/>
           <p:nvPr/>
         </p:nvSpPr>
@@ -42343,7 +42708,7 @@
       </p:sp>
       <p:sp>
         <p:nvSpPr>
-          <p:cNvPr id="25" name="TextBox 24"/>
+          <p:cNvPr id="34" name="TextBox 33"/>
           <p:cNvSpPr txBox="1"/>
           <p:nvPr/>
         </p:nvSpPr>
@@ -42382,7 +42747,7 @@
       </p:sp>
       <p:sp>
         <p:nvSpPr>
-          <p:cNvPr id="26" name="Rectangle 25"/>
+          <p:cNvPr id="35" name="Rectangle 34"/>
           <p:cNvSpPr/>
           <p:nvPr/>
         </p:nvSpPr>
@@ -42426,7 +42791,7 @@
       </p:sp>
       <p:sp>
         <p:nvSpPr>
-          <p:cNvPr id="27" name="TextBox 26"/>
+          <p:cNvPr id="36" name="TextBox 35"/>
           <p:cNvSpPr txBox="1"/>
           <p:nvPr/>
         </p:nvSpPr>
@@ -42461,7 +42826,7 @@
       </p:sp>
       <p:sp>
         <p:nvSpPr>
-          <p:cNvPr id="28" name="TextBox 27"/>
+          <p:cNvPr id="37" name="TextBox 36"/>
           <p:cNvSpPr txBox="1"/>
           <p:nvPr/>
         </p:nvSpPr>

</xml_diff>